<commit_message>
update: AI Trends EN report with improved formatting
- Bold text rendered as actual pptx bold (not raw **)
- Full content preserved (non-bullet paragraphs included)
- All 10 slides with complete content

Co-Authored-By: Claude Opus 4.6 <noreply@anthropic.com>
</commit_message>
<xml_diff>
--- a/output/ai-trends-en/report.pptx
+++ b/output/ai-trends-en/report.pptx
@@ -3463,7 +3463,7 @@
           <a:lstStyle/>
           <a:p>
             <a:r>
-              <a:rPr>
+              <a:rPr b="0">
                 <a:ea typeface="Apple SD Gothic Neo"/>
                 <a:latin typeface="Apple SD Gothic Neo"/>
               </a:rPr>
@@ -3488,7 +3488,7 @@
           <a:lstStyle/>
           <a:p>
             <a:r>
-              <a:rPr>
+              <a:rPr b="0">
                 <a:ea typeface="Apple SD Gothic Neo"/>
                 <a:latin typeface="Apple SD Gothic Neo"/>
               </a:rPr>
@@ -3531,7 +3531,7 @@
           <a:lstStyle/>
           <a:p>
             <a:r>
-              <a:rPr>
+              <a:rPr b="0">
                 <a:ea typeface="Apple SD Gothic Neo"/>
                 <a:latin typeface="Apple SD Gothic Neo"/>
               </a:rPr>
@@ -3561,109 +3561,137 @@
               </a:spcAft>
             </a:pPr>
             <a:r>
-              <a:rPr>
-                <a:ea typeface="Apple SD Gothic Neo"/>
-                <a:latin typeface="Apple SD Gothic Neo"/>
-              </a:rPr>
-              <a:t>**The Past Year in Review**</a:t>
-            </a:r>
-          </a:p>
-          <a:p>
-            <a:pPr>
-              <a:spcAft>
-                <a:spcPts val="400"/>
-              </a:spcAft>
-            </a:pPr>
-            <a:r>
-              <a:rPr>
-                <a:ea typeface="Apple SD Gothic Neo"/>
-                <a:latin typeface="Apple SD Gothic Neo"/>
-              </a:rPr>
-              <a:t>**The LLM Race: A Five-Way Battle**</a:t>
-            </a:r>
-          </a:p>
-          <a:p>
-            <a:pPr>
-              <a:spcAft>
-                <a:spcPts val="400"/>
-              </a:spcAft>
-            </a:pPr>
-            <a:r>
-              <a:rPr>
-                <a:ea typeface="Apple SD Gothic Neo"/>
-                <a:latin typeface="Apple SD Gothic Neo"/>
-              </a:rPr>
-              <a:t>**MCP: Rise, Limits, and the Native AI Era**</a:t>
-            </a:r>
-          </a:p>
-          <a:p>
-            <a:pPr>
-              <a:spcAft>
-                <a:spcPts val="400"/>
-              </a:spcAft>
-            </a:pPr>
-            <a:r>
-              <a:rPr>
-                <a:ea typeface="Apple SD Gothic Neo"/>
-                <a:latin typeface="Apple SD Gothic Neo"/>
-              </a:rPr>
-              <a:t>**From Vibe Coding to Agentic Engineering**</a:t>
-            </a:r>
-          </a:p>
-          <a:p>
-            <a:pPr>
-              <a:spcAft>
-                <a:spcPts val="400"/>
-              </a:spcAft>
-            </a:pPr>
-            <a:r>
-              <a:rPr>
-                <a:ea typeface="Apple SD Gothic Neo"/>
-                <a:latin typeface="Apple SD Gothic Neo"/>
-              </a:rPr>
-              <a:t>**Context Engineering: The New Essential Skill**</a:t>
-            </a:r>
-          </a:p>
-          <a:p>
-            <a:pPr>
-              <a:spcAft>
-                <a:spcPts val="400"/>
-              </a:spcAft>
-            </a:pPr>
-            <a:r>
-              <a:rPr>
-                <a:ea typeface="Apple SD Gothic Neo"/>
-                <a:latin typeface="Apple SD Gothic Neo"/>
-              </a:rPr>
-              <a:t>**Agentic AI Deep Dive**</a:t>
-            </a:r>
-          </a:p>
-          <a:p>
-            <a:pPr>
-              <a:spcAft>
-                <a:spcPts val="400"/>
-              </a:spcAft>
-            </a:pPr>
-            <a:r>
-              <a:rPr>
-                <a:ea typeface="Apple SD Gothic Neo"/>
-                <a:latin typeface="Apple SD Gothic Neo"/>
-              </a:rPr>
-              <a:t>**n8n: Making Agentic AI Real**</a:t>
-            </a:r>
-          </a:p>
-          <a:p>
-            <a:pPr>
-              <a:spcAft>
-                <a:spcPts val="400"/>
-              </a:spcAft>
-            </a:pPr>
-            <a:r>
-              <a:rPr>
-                <a:ea typeface="Apple SD Gothic Neo"/>
-                <a:latin typeface="Apple SD Gothic Neo"/>
-              </a:rPr>
-              <a:t>**Conclusion: What We Can Do Right Now**</a:t>
+              <a:rPr b="0">
+                <a:ea typeface="Apple SD Gothic Neo"/>
+                <a:latin typeface="Apple SD Gothic Neo"/>
+              </a:rPr>
+              <a:t>본 보고서에서는 </a:t>
+            </a:r>
+            <a:r>
+              <a:rPr b="1">
+                <a:ea typeface="Apple SD Gothic Neo"/>
+                <a:latin typeface="Apple SD Gothic Neo"/>
+              </a:rPr>
+              <a:t>AI Trends 2025-2026: The Age of Agentic AI</a:t>
+            </a:r>
+            <a:r>
+              <a:rPr b="0">
+                <a:ea typeface="Apple SD Gothic Neo"/>
+                <a:latin typeface="Apple SD Gothic Neo"/>
+              </a:rPr>
+              <a:t>에 대해 8개 섹션으로 나누어 분석하였습니다.</a:t>
+            </a:r>
+          </a:p>
+          <a:p>
+            <a:pPr>
+              <a:spcAft>
+                <a:spcPts val="400"/>
+              </a:spcAft>
+            </a:pPr>
+            <a:r>
+              <a:rPr b="1">
+                <a:ea typeface="Apple SD Gothic Neo"/>
+                <a:latin typeface="Apple SD Gothic Neo"/>
+              </a:rPr>
+              <a:t>The Past Year in Review</a:t>
+            </a:r>
+          </a:p>
+          <a:p>
+            <a:pPr>
+              <a:spcAft>
+                <a:spcPts val="400"/>
+              </a:spcAft>
+            </a:pPr>
+            <a:r>
+              <a:rPr b="1">
+                <a:ea typeface="Apple SD Gothic Neo"/>
+                <a:latin typeface="Apple SD Gothic Neo"/>
+              </a:rPr>
+              <a:t>The LLM Race: A Five-Way Battle</a:t>
+            </a:r>
+          </a:p>
+          <a:p>
+            <a:pPr>
+              <a:spcAft>
+                <a:spcPts val="400"/>
+              </a:spcAft>
+            </a:pPr>
+            <a:r>
+              <a:rPr b="1">
+                <a:ea typeface="Apple SD Gothic Neo"/>
+                <a:latin typeface="Apple SD Gothic Neo"/>
+              </a:rPr>
+              <a:t>MCP: Rise, Limits, and the Native AI Era</a:t>
+            </a:r>
+          </a:p>
+          <a:p>
+            <a:pPr>
+              <a:spcAft>
+                <a:spcPts val="400"/>
+              </a:spcAft>
+            </a:pPr>
+            <a:r>
+              <a:rPr b="1">
+                <a:ea typeface="Apple SD Gothic Neo"/>
+                <a:latin typeface="Apple SD Gothic Neo"/>
+              </a:rPr>
+              <a:t>From Vibe Coding to Agentic Engineering</a:t>
+            </a:r>
+          </a:p>
+          <a:p>
+            <a:pPr>
+              <a:spcAft>
+                <a:spcPts val="400"/>
+              </a:spcAft>
+            </a:pPr>
+            <a:r>
+              <a:rPr b="1">
+                <a:ea typeface="Apple SD Gothic Neo"/>
+                <a:latin typeface="Apple SD Gothic Neo"/>
+              </a:rPr>
+              <a:t>Context Engineering: The New Essential Skill</a:t>
+            </a:r>
+          </a:p>
+          <a:p>
+            <a:pPr>
+              <a:spcAft>
+                <a:spcPts val="400"/>
+              </a:spcAft>
+            </a:pPr>
+            <a:r>
+              <a:rPr b="1">
+                <a:ea typeface="Apple SD Gothic Neo"/>
+                <a:latin typeface="Apple SD Gothic Neo"/>
+              </a:rPr>
+              <a:t>Agentic AI Deep Dive</a:t>
+            </a:r>
+          </a:p>
+          <a:p>
+            <a:pPr>
+              <a:spcAft>
+                <a:spcPts val="400"/>
+              </a:spcAft>
+            </a:pPr>
+            <a:r>
+              <a:rPr b="1">
+                <a:ea typeface="Apple SD Gothic Neo"/>
+                <a:latin typeface="Apple SD Gothic Neo"/>
+              </a:rPr>
+              <a:t>n8n: Making Agentic AI Real</a:t>
+            </a:r>
+          </a:p>
+          <a:p>
+            <a:pPr>
+              <a:spcAft>
+                <a:spcPts val="400"/>
+              </a:spcAft>
+            </a:pPr>
+            <a:r>
+              <a:rPr b="1">
+                <a:ea typeface="Apple SD Gothic Neo"/>
+                <a:latin typeface="Apple SD Gothic Neo"/>
+              </a:rPr>
+              <a:t>Conclusion: What We Can Do Right Now</a:t>
             </a:r>
           </a:p>
         </p:txBody>
@@ -3702,7 +3730,7 @@
           <a:lstStyle/>
           <a:p>
             <a:r>
-              <a:rPr>
+              <a:rPr b="0">
                 <a:ea typeface="Apple SD Gothic Neo"/>
                 <a:latin typeface="Apple SD Gothic Neo"/>
               </a:rPr>
@@ -3732,137 +3760,228 @@
               </a:spcAft>
             </a:pPr>
             <a:r>
-              <a:rPr>
-                <a:ea typeface="Apple SD Gothic Neo"/>
-                <a:latin typeface="Apple SD Gothic Neo"/>
-              </a:rPr>
-              <a:t>**2024.11** MCP announced (Anthropic) — AI-to-tool connectivity standard emerges</a:t>
-            </a:r>
-          </a:p>
-          <a:p>
-            <a:pPr>
-              <a:spcAft>
-                <a:spcPts val="400"/>
-              </a:spcAft>
-            </a:pPr>
-            <a:r>
-              <a:rPr>
-                <a:ea typeface="Apple SD Gothic Neo"/>
-                <a:latin typeface="Apple SD Gothic Neo"/>
-              </a:rPr>
-              <a:t>**2025.01** DeepSeek R1 released — open-source shockwave, price war begins</a:t>
-            </a:r>
-          </a:p>
-          <a:p>
-            <a:pPr>
-              <a:spcAft>
-                <a:spcPts val="400"/>
-              </a:spcAft>
-            </a:pPr>
-            <a:r>
-              <a:rPr>
-                <a:ea typeface="Apple SD Gothic Neo"/>
-                <a:latin typeface="Apple SD Gothic Neo"/>
-              </a:rPr>
-              <a:t>**2025.02** "Vibe Coding" coined (Karpathy) — writing code without reading it</a:t>
-            </a:r>
-          </a:p>
-          <a:p>
-            <a:pPr>
-              <a:spcAft>
-                <a:spcPts val="400"/>
-              </a:spcAft>
-            </a:pPr>
-            <a:r>
-              <a:rPr>
-                <a:ea typeface="Apple SD Gothic Neo"/>
-                <a:latin typeface="Apple SD Gothic Neo"/>
-              </a:rPr>
-              <a:t>**2025.03** OpenAI Agents SDK — agent framework competition heats up</a:t>
-            </a:r>
-          </a:p>
-          <a:p>
-            <a:pPr>
-              <a:spcAft>
-                <a:spcPts val="400"/>
-              </a:spcAft>
-            </a:pPr>
-            <a:r>
-              <a:rPr>
-                <a:ea typeface="Apple SD Gothic Neo"/>
-                <a:latin typeface="Apple SD Gothic Neo"/>
-              </a:rPr>
-              <a:t>**2025.05** Claude Code launched — CLI-based AI agents begin</a:t>
-            </a:r>
-          </a:p>
-          <a:p>
-            <a:pPr>
-              <a:spcAft>
-                <a:spcPts val="400"/>
-              </a:spcAft>
-            </a:pPr>
-            <a:r>
-              <a:rPr>
-                <a:ea typeface="Apple SD Gothic Neo"/>
-                <a:latin typeface="Apple SD Gothic Neo"/>
-              </a:rPr>
-              <a:t>**2025.09** Notion 3.0 AI Agents — services embed their own AI agents</a:t>
-            </a:r>
-          </a:p>
-          <a:p>
-            <a:pPr>
-              <a:spcAft>
-                <a:spcPts val="400"/>
-              </a:spcAft>
-            </a:pPr>
-            <a:r>
-              <a:rPr>
-                <a:ea typeface="Apple SD Gothic Neo"/>
-                <a:latin typeface="Apple SD Gothic Neo"/>
-              </a:rPr>
-              <a:t>**2025.10** n8n Series C $180M (Nvidia) — massive bet on workflow + AI</a:t>
-            </a:r>
-          </a:p>
-          <a:p>
-            <a:pPr>
-              <a:spcAft>
-                <a:spcPts val="400"/>
-              </a:spcAft>
-            </a:pPr>
-            <a:r>
-              <a:rPr>
-                <a:ea typeface="Apple SD Gothic Neo"/>
-                <a:latin typeface="Apple SD Gothic Neo"/>
-              </a:rPr>
-              <a:t>**2025.12** MCP → Linux Foundation — standard established, industry moves on</a:t>
-            </a:r>
-          </a:p>
-          <a:p>
-            <a:pPr>
-              <a:spcAft>
-                <a:spcPts val="400"/>
-              </a:spcAft>
-            </a:pPr>
-            <a:r>
-              <a:rPr>
-                <a:ea typeface="Apple SD Gothic Neo"/>
-                <a:latin typeface="Apple SD Gothic Neo"/>
-              </a:rPr>
-              <a:t>**2026.01** OpenClaw viral (250K stars) — peak and controversy of vibe coding</a:t>
-            </a:r>
-          </a:p>
-          <a:p>
-            <a:pPr>
-              <a:spcAft>
-                <a:spcPts val="400"/>
-              </a:spcAft>
-            </a:pPr>
-            <a:r>
-              <a:rPr>
-                <a:ea typeface="Apple SD Gothic Neo"/>
-                <a:latin typeface="Apple SD Gothic Neo"/>
-              </a:rPr>
-              <a:t>**2026.02** Claude 4.6 / Karpathy: "Vibe coding is behind us" — agentic engineering era</a:t>
+              <a:rPr b="1">
+                <a:ea typeface="Apple SD Gothic Neo"/>
+                <a:latin typeface="Apple SD Gothic Neo"/>
+              </a:rPr>
+              <a:t>2024.11</a:t>
+            </a:r>
+            <a:r>
+              <a:rPr b="0">
+                <a:ea typeface="Apple SD Gothic Neo"/>
+                <a:latin typeface="Apple SD Gothic Neo"/>
+              </a:rPr>
+              <a:t> MCP announced (Anthropic) — AI-to-tool connectivity standard emerges</a:t>
+            </a:r>
+          </a:p>
+          <a:p>
+            <a:pPr>
+              <a:spcAft>
+                <a:spcPts val="400"/>
+              </a:spcAft>
+            </a:pPr>
+            <a:r>
+              <a:rPr b="1">
+                <a:ea typeface="Apple SD Gothic Neo"/>
+                <a:latin typeface="Apple SD Gothic Neo"/>
+              </a:rPr>
+              <a:t>2025.01</a:t>
+            </a:r>
+            <a:r>
+              <a:rPr b="0">
+                <a:ea typeface="Apple SD Gothic Neo"/>
+                <a:latin typeface="Apple SD Gothic Neo"/>
+              </a:rPr>
+              <a:t> DeepSeek R1 released — open-source shockwave, price war begins</a:t>
+            </a:r>
+          </a:p>
+          <a:p>
+            <a:pPr>
+              <a:spcAft>
+                <a:spcPts val="400"/>
+              </a:spcAft>
+            </a:pPr>
+            <a:r>
+              <a:rPr b="1">
+                <a:ea typeface="Apple SD Gothic Neo"/>
+                <a:latin typeface="Apple SD Gothic Neo"/>
+              </a:rPr>
+              <a:t>2025.02</a:t>
+            </a:r>
+            <a:r>
+              <a:rPr b="0">
+                <a:ea typeface="Apple SD Gothic Neo"/>
+                <a:latin typeface="Apple SD Gothic Neo"/>
+              </a:rPr>
+              <a:t> "Vibe Coding" coined (Karpathy) — writing code without reading it</a:t>
+            </a:r>
+          </a:p>
+          <a:p>
+            <a:pPr>
+              <a:spcAft>
+                <a:spcPts val="400"/>
+              </a:spcAft>
+            </a:pPr>
+            <a:r>
+              <a:rPr b="1">
+                <a:ea typeface="Apple SD Gothic Neo"/>
+                <a:latin typeface="Apple SD Gothic Neo"/>
+              </a:rPr>
+              <a:t>2025.03</a:t>
+            </a:r>
+            <a:r>
+              <a:rPr b="0">
+                <a:ea typeface="Apple SD Gothic Neo"/>
+                <a:latin typeface="Apple SD Gothic Neo"/>
+              </a:rPr>
+              <a:t> OpenAI Agents SDK — agent framework competition heats up</a:t>
+            </a:r>
+          </a:p>
+          <a:p>
+            <a:pPr>
+              <a:spcAft>
+                <a:spcPts val="400"/>
+              </a:spcAft>
+            </a:pPr>
+            <a:r>
+              <a:rPr b="1">
+                <a:ea typeface="Apple SD Gothic Neo"/>
+                <a:latin typeface="Apple SD Gothic Neo"/>
+              </a:rPr>
+              <a:t>2025.05</a:t>
+            </a:r>
+            <a:r>
+              <a:rPr b="0">
+                <a:ea typeface="Apple SD Gothic Neo"/>
+                <a:latin typeface="Apple SD Gothic Neo"/>
+              </a:rPr>
+              <a:t> Claude Code launched — CLI-based AI agents begin</a:t>
+            </a:r>
+          </a:p>
+          <a:p>
+            <a:pPr>
+              <a:spcAft>
+                <a:spcPts val="400"/>
+              </a:spcAft>
+            </a:pPr>
+            <a:r>
+              <a:rPr b="1">
+                <a:ea typeface="Apple SD Gothic Neo"/>
+                <a:latin typeface="Apple SD Gothic Neo"/>
+              </a:rPr>
+              <a:t>2025.09</a:t>
+            </a:r>
+            <a:r>
+              <a:rPr b="0">
+                <a:ea typeface="Apple SD Gothic Neo"/>
+                <a:latin typeface="Apple SD Gothic Neo"/>
+              </a:rPr>
+              <a:t> Notion 3.0 AI Agents — services embed their own AI agents</a:t>
+            </a:r>
+          </a:p>
+          <a:p>
+            <a:pPr>
+              <a:spcAft>
+                <a:spcPts val="400"/>
+              </a:spcAft>
+            </a:pPr>
+            <a:r>
+              <a:rPr b="1">
+                <a:ea typeface="Apple SD Gothic Neo"/>
+                <a:latin typeface="Apple SD Gothic Neo"/>
+              </a:rPr>
+              <a:t>2025.10</a:t>
+            </a:r>
+            <a:r>
+              <a:rPr b="0">
+                <a:ea typeface="Apple SD Gothic Neo"/>
+                <a:latin typeface="Apple SD Gothic Neo"/>
+              </a:rPr>
+              <a:t> n8n Series C $180M (Nvidia) — massive bet on workflow + AI</a:t>
+            </a:r>
+          </a:p>
+          <a:p>
+            <a:pPr>
+              <a:spcAft>
+                <a:spcPts val="400"/>
+              </a:spcAft>
+            </a:pPr>
+            <a:r>
+              <a:rPr b="1">
+                <a:ea typeface="Apple SD Gothic Neo"/>
+                <a:latin typeface="Apple SD Gothic Neo"/>
+              </a:rPr>
+              <a:t>2025.12</a:t>
+            </a:r>
+            <a:r>
+              <a:rPr b="0">
+                <a:ea typeface="Apple SD Gothic Neo"/>
+                <a:latin typeface="Apple SD Gothic Neo"/>
+              </a:rPr>
+              <a:t> MCP → Linux Foundation — standard established, industry moves on</a:t>
+            </a:r>
+          </a:p>
+          <a:p>
+            <a:pPr>
+              <a:spcAft>
+                <a:spcPts val="400"/>
+              </a:spcAft>
+            </a:pPr>
+            <a:r>
+              <a:rPr b="1">
+                <a:ea typeface="Apple SD Gothic Neo"/>
+                <a:latin typeface="Apple SD Gothic Neo"/>
+              </a:rPr>
+              <a:t>2026.01</a:t>
+            </a:r>
+            <a:r>
+              <a:rPr b="0">
+                <a:ea typeface="Apple SD Gothic Neo"/>
+                <a:latin typeface="Apple SD Gothic Neo"/>
+              </a:rPr>
+              <a:t> OpenClaw viral (250K stars) — peak and controversy of vibe coding</a:t>
+            </a:r>
+          </a:p>
+          <a:p>
+            <a:pPr>
+              <a:spcAft>
+                <a:spcPts val="400"/>
+              </a:spcAft>
+            </a:pPr>
+            <a:r>
+              <a:rPr b="1">
+                <a:ea typeface="Apple SD Gothic Neo"/>
+                <a:latin typeface="Apple SD Gothic Neo"/>
+              </a:rPr>
+              <a:t>2026.02</a:t>
+            </a:r>
+            <a:r>
+              <a:rPr b="0">
+                <a:ea typeface="Apple SD Gothic Neo"/>
+                <a:latin typeface="Apple SD Gothic Neo"/>
+              </a:rPr>
+              <a:t> Claude 4.6 / Karpathy: "Vibe coding is behind us" — agentic engineering era</a:t>
+            </a:r>
+          </a:p>
+          <a:p>
+            <a:pPr>
+              <a:spcAft>
+                <a:spcPts val="400"/>
+              </a:spcAft>
+            </a:pPr>
+            <a:r>
+              <a:rPr b="1">
+                <a:ea typeface="Apple SD Gothic Neo"/>
+                <a:latin typeface="Apple SD Gothic Neo"/>
+              </a:rPr>
+              <a:t>In one line:</a:t>
+            </a:r>
+            <a:r>
+              <a:rPr b="0">
+                <a:ea typeface="Apple SD Gothic Neo"/>
+                <a:latin typeface="Apple SD Gothic Neo"/>
+              </a:rPr>
+              <a:t> AI evolves from "conversation tool" → "working agent" → "a team that runs systems."</a:t>
             </a:r>
           </a:p>
         </p:txBody>
@@ -3901,7 +4020,7 @@
           <a:lstStyle/>
           <a:p>
             <a:r>
-              <a:rPr>
+              <a:rPr b="0">
                 <a:ea typeface="Apple SD Gothic Neo"/>
                 <a:latin typeface="Apple SD Gothic Neo"/>
               </a:rPr>
@@ -3924,7 +4043,15 @@
         <p:txBody>
           <a:bodyPr/>
           <a:lstStyle/>
-          <a:p/>
+          <a:p>
+            <a:r>
+              <a:rPr b="0">
+                <a:ea typeface="Apple SD Gothic Neo"/>
+                <a:latin typeface="Apple SD Gothic Neo"/>
+              </a:rPr>
+              <a:t/>
+            </a:r>
+          </a:p>
         </p:txBody>
       </p:sp>
       <p:sp>
@@ -3948,53 +4075,95 @@
               </a:spcAft>
             </a:pPr>
             <a:r>
-              <a:rPr>
-                <a:ea typeface="Apple SD Gothic Neo"/>
-                <a:latin typeface="Apple SD Gothic Neo"/>
-              </a:rPr>
-              <a:t>**OpenAI** — GPT-4.1, o3, o4-mini: Reasoning-focused, 1M tokens, price competitive</a:t>
-            </a:r>
-          </a:p>
-          <a:p>
-            <a:pPr>
-              <a:spcAft>
-                <a:spcPts val="400"/>
-              </a:spcAft>
-            </a:pPr>
-            <a:r>
-              <a:rPr>
-                <a:ea typeface="Apple SD Gothic Neo"/>
-                <a:latin typeface="Apple SD Gothic Neo"/>
-              </a:rPr>
-              <a:t>**Anthropic** — Claude Sonnet/Opus 4.6: #1 coding, 30h+ autonomous tasks, agent teams</a:t>
-            </a:r>
-          </a:p>
-          <a:p>
-            <a:pPr>
-              <a:spcAft>
-                <a:spcPts val="400"/>
-              </a:spcAft>
-            </a:pPr>
-            <a:r>
-              <a:rPr>
-                <a:ea typeface="Apple SD Gothic Neo"/>
-                <a:latin typeface="Apple SD Gothic Neo"/>
-              </a:rPr>
-              <a:t>**Google** — Gemini 2.5 Pro: 1M tokens, Deep Think mode, top math/coding</a:t>
-            </a:r>
-          </a:p>
-          <a:p>
-            <a:pPr>
-              <a:spcAft>
-                <a:spcPts val="400"/>
-              </a:spcAft>
-            </a:pPr>
-            <a:r>
-              <a:rPr>
-                <a:ea typeface="Apple SD Gothic Neo"/>
-                <a:latin typeface="Apple SD Gothic Neo"/>
-              </a:rPr>
-              <a:t>**Open Source** — DeepSeek R1, Llama 4 Scout (10M tokens): Price disruption + rapid catch-up</a:t>
+              <a:rPr b="1">
+                <a:ea typeface="Apple SD Gothic Neo"/>
+                <a:latin typeface="Apple SD Gothic Neo"/>
+              </a:rPr>
+              <a:t>The Big 5:</a:t>
+            </a:r>
+          </a:p>
+          <a:p>
+            <a:pPr>
+              <a:spcAft>
+                <a:spcPts val="400"/>
+              </a:spcAft>
+            </a:pPr>
+            <a:r>
+              <a:rPr b="1">
+                <a:ea typeface="Apple SD Gothic Neo"/>
+                <a:latin typeface="Apple SD Gothic Neo"/>
+              </a:rPr>
+              <a:t>OpenAI</a:t>
+            </a:r>
+            <a:r>
+              <a:rPr b="0">
+                <a:ea typeface="Apple SD Gothic Neo"/>
+                <a:latin typeface="Apple SD Gothic Neo"/>
+              </a:rPr>
+              <a:t> — GPT-4.1, o3, o4-mini: Reasoning-focused, 1M tokens, price competitive</a:t>
+            </a:r>
+          </a:p>
+          <a:p>
+            <a:pPr>
+              <a:spcAft>
+                <a:spcPts val="400"/>
+              </a:spcAft>
+            </a:pPr>
+            <a:r>
+              <a:rPr b="1">
+                <a:ea typeface="Apple SD Gothic Neo"/>
+                <a:latin typeface="Apple SD Gothic Neo"/>
+              </a:rPr>
+              <a:t>Anthropic</a:t>
+            </a:r>
+            <a:r>
+              <a:rPr b="0">
+                <a:ea typeface="Apple SD Gothic Neo"/>
+                <a:latin typeface="Apple SD Gothic Neo"/>
+              </a:rPr>
+              <a:t> — Claude Sonnet/Opus 4.6: #1 coding, 30h+ autonomous tasks, agent teams</a:t>
+            </a:r>
+          </a:p>
+          <a:p>
+            <a:pPr>
+              <a:spcAft>
+                <a:spcPts val="400"/>
+              </a:spcAft>
+            </a:pPr>
+            <a:r>
+              <a:rPr b="1">
+                <a:ea typeface="Apple SD Gothic Neo"/>
+                <a:latin typeface="Apple SD Gothic Neo"/>
+              </a:rPr>
+              <a:t>Google</a:t>
+            </a:r>
+            <a:r>
+              <a:rPr b="0">
+                <a:ea typeface="Apple SD Gothic Neo"/>
+                <a:latin typeface="Apple SD Gothic Neo"/>
+              </a:rPr>
+              <a:t> — Gemini 2.5 Pro: 1M tokens, Deep Think mode, top math/coding</a:t>
+            </a:r>
+          </a:p>
+          <a:p>
+            <a:pPr>
+              <a:spcAft>
+                <a:spcPts val="400"/>
+              </a:spcAft>
+            </a:pPr>
+            <a:r>
+              <a:rPr b="1">
+                <a:ea typeface="Apple SD Gothic Neo"/>
+                <a:latin typeface="Apple SD Gothic Neo"/>
+              </a:rPr>
+              <a:t>Open Source</a:t>
+            </a:r>
+            <a:r>
+              <a:rPr b="0">
+                <a:ea typeface="Apple SD Gothic Neo"/>
+                <a:latin typeface="Apple SD Gothic Neo"/>
+              </a:rPr>
+              <a:t> — DeepSeek R1, Llama 4 Scout (10M tokens): Price disruption + rapid catch-up</a:t>
             </a:r>
           </a:p>
         </p:txBody>
@@ -4013,7 +4182,15 @@
         <p:txBody>
           <a:bodyPr/>
           <a:lstStyle/>
-          <a:p/>
+          <a:p>
+            <a:r>
+              <a:rPr b="0">
+                <a:ea typeface="Apple SD Gothic Neo"/>
+                <a:latin typeface="Apple SD Gothic Neo"/>
+              </a:rPr>
+              <a:t/>
+            </a:r>
+          </a:p>
         </p:txBody>
       </p:sp>
       <p:sp>
@@ -4037,21 +4214,42 @@
               </a:spcAft>
             </a:pPr>
             <a:r>
-              <a:rPr>
-                <a:ea typeface="Apple SD Gothic Neo"/>
-                <a:latin typeface="Apple SD Gothic Neo"/>
-              </a:rPr>
-              <a:t>**Challengers** — xAI Grok 3, Mistral: 200K GPU infra, EU data sovereignty</a:t>
-            </a:r>
-          </a:p>
-          <a:p>
-            <a:pPr>
-              <a:spcAft>
-                <a:spcPts val="400"/>
-              </a:spcAft>
-            </a:pPr>
-            <a:r>
-              <a:rPr>
+              <a:rPr b="1">
+                <a:ea typeface="Apple SD Gothic Neo"/>
+                <a:latin typeface="Apple SD Gothic Neo"/>
+              </a:rPr>
+              <a:t>Challengers</a:t>
+            </a:r>
+            <a:r>
+              <a:rPr b="0">
+                <a:ea typeface="Apple SD Gothic Neo"/>
+                <a:latin typeface="Apple SD Gothic Neo"/>
+              </a:rPr>
+              <a:t> — xAI Grok 3, Mistral: 200K GPU infra, EU data sovereignty</a:t>
+            </a:r>
+          </a:p>
+          <a:p>
+            <a:pPr>
+              <a:spcAft>
+                <a:spcPts val="400"/>
+              </a:spcAft>
+            </a:pPr>
+            <a:r>
+              <a:rPr b="1">
+                <a:ea typeface="Apple SD Gothic Neo"/>
+                <a:latin typeface="Apple SD Gothic Neo"/>
+              </a:rPr>
+              <a:t>How competition shifted:</a:t>
+            </a:r>
+          </a:p>
+          <a:p>
+            <a:pPr>
+              <a:spcAft>
+                <a:spcPts val="400"/>
+              </a:spcAft>
+            </a:pPr>
+            <a:r>
+              <a:rPr b="0">
                 <a:ea typeface="Apple SD Gothic Neo"/>
                 <a:latin typeface="Apple SD Gothic Neo"/>
               </a:rPr>
@@ -4065,7 +4263,7 @@
               </a:spcAft>
             </a:pPr>
             <a:r>
-              <a:rPr>
+              <a:rPr b="0">
                 <a:ea typeface="Apple SD Gothic Neo"/>
                 <a:latin typeface="Apple SD Gothic Neo"/>
               </a:rPr>
@@ -4079,11 +4277,25 @@
               </a:spcAft>
             </a:pPr>
             <a:r>
-              <a:rPr>
+              <a:rPr b="0">
                 <a:ea typeface="Apple SD Gothic Neo"/>
                 <a:latin typeface="Apple SD Gothic Neo"/>
               </a:rPr>
               <a:t>2026: How well can it orchestrate agent teams?</a:t>
+            </a:r>
+          </a:p>
+          <a:p>
+            <a:pPr>
+              <a:spcAft>
+                <a:spcPts val="400"/>
+              </a:spcAft>
+            </a:pPr>
+            <a:r>
+              <a:rPr b="0">
+                <a:ea typeface="Apple SD Gothic Neo"/>
+                <a:latin typeface="Apple SD Gothic Neo"/>
+              </a:rPr>
+              <a:t>Every model now ships with reasoning mode. Agent capability is the new metric. Prices dropping across the board.</a:t>
             </a:r>
           </a:p>
         </p:txBody>
@@ -4122,7 +4334,7 @@
           <a:lstStyle/>
           <a:p>
             <a:r>
-              <a:rPr>
+              <a:rPr b="0">
                 <a:ea typeface="Apple SD Gothic Neo"/>
                 <a:latin typeface="Apple SD Gothic Neo"/>
               </a:rPr>
@@ -4152,7 +4364,91 @@
               </a:spcAft>
             </a:pPr>
             <a:r>
-              <a:rPr>
+              <a:rPr b="1">
+                <a:ea typeface="Apple SD Gothic Neo"/>
+                <a:latin typeface="Apple SD Gothic Neo"/>
+              </a:rPr>
+              <a:t>Model Context Protocol</a:t>
+            </a:r>
+            <a:r>
+              <a:rPr b="0">
+                <a:ea typeface="Apple SD Gothic Neo"/>
+                <a:latin typeface="Apple SD Gothic Neo"/>
+              </a:rPr>
+              <a:t> — universal standard for AI ↔ tool connectivity</a:t>
+            </a:r>
+          </a:p>
+          <a:p>
+            <a:pPr>
+              <a:spcAft>
+                <a:spcPts val="400"/>
+              </a:spcAft>
+            </a:pPr>
+            <a:r>
+              <a:rPr b="0">
+                <a:ea typeface="Apple SD Gothic Neo"/>
+                <a:latin typeface="Apple SD Gothic Neo"/>
+              </a:rPr>
+              <a:t>Before: M models × N tools = custom code each (M×N)</a:t>
+            </a:r>
+          </a:p>
+          <a:p>
+            <a:pPr>
+              <a:spcAft>
+                <a:spcPts val="400"/>
+              </a:spcAft>
+            </a:pPr>
+            <a:r>
+              <a:rPr b="0">
+                <a:ea typeface="Apple SD Gothic Neo"/>
+                <a:latin typeface="Apple SD Gothic Neo"/>
+              </a:rPr>
+              <a:t>After: M models + N MCP servers = standard protocol (M+N)</a:t>
+            </a:r>
+          </a:p>
+          <a:p>
+            <a:pPr>
+              <a:spcAft>
+                <a:spcPts val="400"/>
+              </a:spcAft>
+            </a:pPr>
+            <a:r>
+              <a:rPr b="1">
+                <a:ea typeface="Apple SD Gothic Neo"/>
+                <a:latin typeface="Apple SD Gothic Neo"/>
+              </a:rPr>
+              <a:t>Scale:</a:t>
+            </a:r>
+            <a:r>
+              <a:rPr b="0">
+                <a:ea typeface="Apple SD Gothic Neo"/>
+                <a:latin typeface="Apple SD Gothic Neo"/>
+              </a:rPr>
+              <a:t> 5,800+ servers, 300+ clients, 97M SDK downloads/month</a:t>
+            </a:r>
+          </a:p>
+          <a:p>
+            <a:pPr>
+              <a:spcAft>
+                <a:spcPts val="400"/>
+              </a:spcAft>
+            </a:pPr>
+            <a:r>
+              <a:rPr b="1">
+                <a:ea typeface="Apple SD Gothic Neo"/>
+                <a:latin typeface="Apple SD Gothic Neo"/>
+              </a:rPr>
+              <a:t>But MCP is showing its age:</a:t>
+            </a:r>
+          </a:p>
+          <a:p>
+            <a:pPr>
+              <a:spcAft>
+                <a:spcPts val="400"/>
+              </a:spcAft>
+            </a:pPr>
+            <a:r>
+              <a:rPr b="0">
                 <a:ea typeface="Apple SD Gothic Neo"/>
                 <a:latin typeface="Apple SD Gothic Neo"/>
               </a:rPr>
@@ -4166,7 +4462,7 @@
               </a:spcAft>
             </a:pPr>
             <a:r>
-              <a:rPr>
+              <a:rPr b="0">
                 <a:ea typeface="Apple SD Gothic Neo"/>
                 <a:latin typeface="Apple SD Gothic Neo"/>
               </a:rPr>
@@ -4180,7 +4476,7 @@
               </a:spcAft>
             </a:pPr>
             <a:r>
-              <a:rPr>
+              <a:rPr b="0">
                 <a:ea typeface="Apple SD Gothic Neo"/>
                 <a:latin typeface="Apple SD Gothic Neo"/>
               </a:rPr>
@@ -4194,7 +4490,21 @@
               </a:spcAft>
             </a:pPr>
             <a:r>
-              <a:rPr>
+              <a:rPr b="1">
+                <a:ea typeface="Apple SD Gothic Neo"/>
+                <a:latin typeface="Apple SD Gothic Neo"/>
+              </a:rPr>
+              <a:t>Where MCP stands:</a:t>
+            </a:r>
+          </a:p>
+          <a:p>
+            <a:pPr>
+              <a:spcAft>
+                <a:spcPts val="400"/>
+              </a:spcAft>
+            </a:pPr>
+            <a:r>
+              <a:rPr b="0">
                 <a:ea typeface="Apple SD Gothic Neo"/>
                 <a:latin typeface="Apple SD Gothic Neo"/>
               </a:rPr>
@@ -4208,7 +4518,7 @@
               </a:spcAft>
             </a:pPr>
             <a:r>
-              <a:rPr>
+              <a:rPr b="0">
                 <a:ea typeface="Apple SD Gothic Neo"/>
                 <a:latin typeface="Apple SD Gothic Neo"/>
               </a:rPr>
@@ -4222,7 +4532,7 @@
               </a:spcAft>
             </a:pPr>
             <a:r>
-              <a:rPr>
+              <a:rPr b="0">
                 <a:ea typeface="Apple SD Gothic Neo"/>
                 <a:latin typeface="Apple SD Gothic Neo"/>
               </a:rPr>
@@ -4265,7 +4575,7 @@
           <a:lstStyle/>
           <a:p>
             <a:r>
-              <a:rPr>
+              <a:rPr b="0">
                 <a:ea typeface="Apple SD Gothic Neo"/>
                 <a:latin typeface="Apple SD Gothic Neo"/>
               </a:rPr>
@@ -4295,7 +4605,21 @@
               </a:spcAft>
             </a:pPr>
             <a:r>
-              <a:rPr>
+              <a:rPr b="1">
+                <a:ea typeface="Apple SD Gothic Neo"/>
+                <a:latin typeface="Apple SD Gothic Neo"/>
+              </a:rPr>
+              <a:t>Evolution of AI Coding Tools:</a:t>
+            </a:r>
+          </a:p>
+          <a:p>
+            <a:pPr>
+              <a:spcAft>
+                <a:spcPts val="400"/>
+              </a:spcAft>
+            </a:pPr>
+            <a:r>
+              <a:rPr b="0">
                 <a:ea typeface="Apple SD Gothic Neo"/>
                 <a:latin typeface="Apple SD Gothic Neo"/>
               </a:rPr>
@@ -4309,7 +4633,7 @@
               </a:spcAft>
             </a:pPr>
             <a:r>
-              <a:rPr>
+              <a:rPr b="0">
                 <a:ea typeface="Apple SD Gothic Neo"/>
                 <a:latin typeface="Apple SD Gothic Neo"/>
               </a:rPr>
@@ -4323,7 +4647,7 @@
               </a:spcAft>
             </a:pPr>
             <a:r>
-              <a:rPr>
+              <a:rPr b="0">
                 <a:ea typeface="Apple SD Gothic Neo"/>
                 <a:latin typeface="Apple SD Gothic Neo"/>
               </a:rPr>
@@ -4337,7 +4661,7 @@
               </a:spcAft>
             </a:pPr>
             <a:r>
-              <a:rPr>
+              <a:rPr b="0">
                 <a:ea typeface="Apple SD Gothic Neo"/>
                 <a:latin typeface="Apple SD Gothic Neo"/>
               </a:rPr>
@@ -4351,7 +4675,77 @@
               </a:spcAft>
             </a:pPr>
             <a:r>
-              <a:rPr>
+              <a:rPr b="1">
+                <a:ea typeface="Apple SD Gothic Neo"/>
+                <a:latin typeface="Apple SD Gothic Neo"/>
+              </a:rPr>
+              <a:t>Claude Code:</a:t>
+            </a:r>
+            <a:r>
+              <a:rPr b="0">
+                <a:ea typeface="Apple SD Gothic Neo"/>
+                <a:latin typeface="Apple SD Gothic Neo"/>
+              </a:rPr>
+              <a:t> #1 developer preference (46%) within 8 months of launch</a:t>
+            </a:r>
+          </a:p>
+          <a:p>
+            <a:pPr>
+              <a:spcAft>
+                <a:spcPts val="400"/>
+              </a:spcAft>
+            </a:pPr>
+            <a:r>
+              <a:rPr b="1">
+                <a:ea typeface="Apple SD Gothic Neo"/>
+                <a:latin typeface="Apple SD Gothic Neo"/>
+              </a:rPr>
+              <a:t>95%</a:t>
+            </a:r>
+            <a:r>
+              <a:rPr b="0">
+                <a:ea typeface="Apple SD Gothic Neo"/>
+                <a:latin typeface="Apple SD Gothic Neo"/>
+              </a:rPr>
+              <a:t> of developers use AI tools weekly; </a:t>
+            </a:r>
+            <a:r>
+              <a:rPr b="1">
+                <a:ea typeface="Apple SD Gothic Neo"/>
+                <a:latin typeface="Apple SD Gothic Neo"/>
+              </a:rPr>
+              <a:t>75%</a:t>
+            </a:r>
+            <a:r>
+              <a:rPr b="0">
+                <a:ea typeface="Apple SD Gothic Neo"/>
+                <a:latin typeface="Apple SD Gothic Neo"/>
+              </a:rPr>
+              <a:t> use AI for &gt;50% of coding</a:t>
+            </a:r>
+          </a:p>
+          <a:p>
+            <a:pPr>
+              <a:spcAft>
+                <a:spcPts val="400"/>
+              </a:spcAft>
+            </a:pPr>
+            <a:r>
+              <a:rPr b="1">
+                <a:ea typeface="Apple SD Gothic Neo"/>
+                <a:latin typeface="Apple SD Gothic Neo"/>
+              </a:rPr>
+              <a:t>Vibe Coding → Agentic Engineering:</a:t>
+            </a:r>
+          </a:p>
+          <a:p>
+            <a:pPr>
+              <a:spcAft>
+                <a:spcPts val="400"/>
+              </a:spcAft>
+            </a:pPr>
+            <a:r>
+              <a:rPr b="0">
                 <a:ea typeface="Apple SD Gothic Neo"/>
                 <a:latin typeface="Apple SD Gothic Neo"/>
               </a:rPr>
@@ -4365,7 +4759,7 @@
               </a:spcAft>
             </a:pPr>
             <a:r>
-              <a:rPr>
+              <a:rPr b="0">
                 <a:ea typeface="Apple SD Gothic Neo"/>
                 <a:latin typeface="Apple SD Gothic Neo"/>
               </a:rPr>
@@ -4379,7 +4773,7 @@
               </a:spcAft>
             </a:pPr>
             <a:r>
-              <a:rPr>
+              <a:rPr b="0">
                 <a:ea typeface="Apple SD Gothic Neo"/>
                 <a:latin typeface="Apple SD Gothic Neo"/>
               </a:rPr>
@@ -4422,7 +4816,7 @@
           <a:lstStyle/>
           <a:p>
             <a:r>
-              <a:rPr>
+              <a:rPr b="0">
                 <a:ea typeface="Apple SD Gothic Neo"/>
                 <a:latin typeface="Apple SD Gothic Neo"/>
               </a:rPr>
@@ -4445,7 +4839,15 @@
         <p:txBody>
           <a:bodyPr/>
           <a:lstStyle/>
-          <a:p/>
+          <a:p>
+            <a:r>
+              <a:rPr b="0">
+                <a:ea typeface="Apple SD Gothic Neo"/>
+                <a:latin typeface="Apple SD Gothic Neo"/>
+              </a:rPr>
+              <a:t/>
+            </a:r>
+          </a:p>
         </p:txBody>
       </p:sp>
       <p:sp>
@@ -4469,7 +4871,35 @@
               </a:spcAft>
             </a:pPr>
             <a:r>
-              <a:rPr>
+              <a:rPr b="1">
+                <a:ea typeface="Apple SD Gothic Neo"/>
+                <a:latin typeface="Apple SD Gothic Neo"/>
+              </a:rPr>
+              <a:t>Prompt Engineering vs Context Engineering:</a:t>
+            </a:r>
+          </a:p>
+          <a:p>
+            <a:pPr>
+              <a:spcAft>
+                <a:spcPts val="400"/>
+              </a:spcAft>
+            </a:pPr>
+            <a:r>
+              <a:rPr b="1">
+                <a:ea typeface="Apple SD Gothic Neo"/>
+                <a:latin typeface="Apple SD Gothic Neo"/>
+              </a:rPr>
+              <a:t>The 7 Elements of Context:</a:t>
+            </a:r>
+          </a:p>
+          <a:p>
+            <a:pPr>
+              <a:spcAft>
+                <a:spcPts val="400"/>
+              </a:spcAft>
+            </a:pPr>
+            <a:r>
+              <a:rPr b="0">
                 <a:ea typeface="Apple SD Gothic Neo"/>
                 <a:latin typeface="Apple SD Gothic Neo"/>
               </a:rPr>
@@ -4483,7 +4913,7 @@
               </a:spcAft>
             </a:pPr>
             <a:r>
-              <a:rPr>
+              <a:rPr b="0">
                 <a:ea typeface="Apple SD Gothic Neo"/>
                 <a:latin typeface="Apple SD Gothic Neo"/>
               </a:rPr>
@@ -4497,7 +4927,7 @@
               </a:spcAft>
             </a:pPr>
             <a:r>
-              <a:rPr>
+              <a:rPr b="0">
                 <a:ea typeface="Apple SD Gothic Neo"/>
                 <a:latin typeface="Apple SD Gothic Neo"/>
               </a:rPr>
@@ -4520,7 +4950,15 @@
         <p:txBody>
           <a:bodyPr/>
           <a:lstStyle/>
-          <a:p/>
+          <a:p>
+            <a:r>
+              <a:rPr b="0">
+                <a:ea typeface="Apple SD Gothic Neo"/>
+                <a:latin typeface="Apple SD Gothic Neo"/>
+              </a:rPr>
+              <a:t/>
+            </a:r>
+          </a:p>
         </p:txBody>
       </p:sp>
       <p:sp>
@@ -4544,7 +4982,7 @@
               </a:spcAft>
             </a:pPr>
             <a:r>
-              <a:rPr>
+              <a:rPr b="0">
                 <a:ea typeface="Apple SD Gothic Neo"/>
                 <a:latin typeface="Apple SD Gothic Neo"/>
               </a:rPr>
@@ -4558,7 +4996,7 @@
               </a:spcAft>
             </a:pPr>
             <a:r>
-              <a:rPr>
+              <a:rPr b="0">
                 <a:ea typeface="Apple SD Gothic Neo"/>
                 <a:latin typeface="Apple SD Gothic Neo"/>
               </a:rPr>
@@ -4572,7 +5010,7 @@
               </a:spcAft>
             </a:pPr>
             <a:r>
-              <a:rPr>
+              <a:rPr b="0">
                 <a:ea typeface="Apple SD Gothic Neo"/>
                 <a:latin typeface="Apple SD Gothic Neo"/>
               </a:rPr>
@@ -4586,11 +5024,25 @@
               </a:spcAft>
             </a:pPr>
             <a:r>
-              <a:rPr>
+              <a:rPr b="0">
                 <a:ea typeface="Apple SD Gothic Neo"/>
                 <a:latin typeface="Apple SD Gothic Neo"/>
               </a:rPr>
               <a:t>Output Format — Structured response definitions</a:t>
+            </a:r>
+          </a:p>
+          <a:p>
+            <a:pPr>
+              <a:spcAft>
+                <a:spcPts val="400"/>
+              </a:spcAft>
+            </a:pPr>
+            <a:r>
+              <a:rPr b="0">
+                <a:ea typeface="Apple SD Gothic Neo"/>
+                <a:latin typeface="Apple SD Gothic Neo"/>
+              </a:rPr>
+              <a:t>Context engineering designs *what* info, *when*, in *what format*, and *how much*.</a:t>
             </a:r>
           </a:p>
         </p:txBody>
@@ -4629,7 +5081,7 @@
           <a:lstStyle/>
           <a:p>
             <a:r>
-              <a:rPr>
+              <a:rPr b="0">
                 <a:ea typeface="Apple SD Gothic Neo"/>
                 <a:latin typeface="Apple SD Gothic Neo"/>
               </a:rPr>
@@ -4659,7 +5111,35 @@
               </a:spcAft>
             </a:pPr>
             <a:r>
-              <a:rPr>
+              <a:rPr b="1">
+                <a:ea typeface="Apple SD Gothic Neo"/>
+                <a:latin typeface="Apple SD Gothic Neo"/>
+              </a:rPr>
+              <a:t>Generative AI "answers" questions. Agentic AI "achieves" goals.</a:t>
+            </a:r>
+          </a:p>
+          <a:p>
+            <a:pPr>
+              <a:spcAft>
+                <a:spcPts val="400"/>
+              </a:spcAft>
+            </a:pPr>
+            <a:r>
+              <a:rPr b="1">
+                <a:ea typeface="Apple SD Gothic Neo"/>
+                <a:latin typeface="Apple SD Gothic Neo"/>
+              </a:rPr>
+              <a:t>Restaurant Analogy:</a:t>
+            </a:r>
+          </a:p>
+          <a:p>
+            <a:pPr>
+              <a:spcAft>
+                <a:spcPts val="400"/>
+              </a:spcAft>
+            </a:pPr>
+            <a:r>
+              <a:rPr b="0">
                 <a:ea typeface="Apple SD Gothic Neo"/>
                 <a:latin typeface="Apple SD Gothic Neo"/>
               </a:rPr>
@@ -4673,7 +5153,7 @@
               </a:spcAft>
             </a:pPr>
             <a:r>
-              <a:rPr>
+              <a:rPr b="0">
                 <a:ea typeface="Apple SD Gothic Neo"/>
                 <a:latin typeface="Apple SD Gothic Neo"/>
               </a:rPr>
@@ -4687,7 +5167,77 @@
               </a:spcAft>
             </a:pPr>
             <a:r>
-              <a:rPr>
+              <a:rPr b="1">
+                <a:ea typeface="Apple SD Gothic Neo"/>
+                <a:latin typeface="Apple SD Gothic Neo"/>
+              </a:rPr>
+              <a:t>The Agentic Loop:</a:t>
+            </a:r>
+            <a:r>
+              <a:rPr b="0">
+                <a:ea typeface="Apple SD Gothic Neo"/>
+                <a:latin typeface="Apple SD Gothic Neo"/>
+              </a:rPr>
+              <a:t> Receive Goal → Plan → Execute Tools → Evaluate → Iterate/Done</a:t>
+            </a:r>
+          </a:p>
+          <a:p>
+            <a:pPr>
+              <a:spcAft>
+                <a:spcPts val="400"/>
+              </a:spcAft>
+            </a:pPr>
+            <a:r>
+              <a:rPr b="0">
+                <a:ea typeface="Apple SD Gothic Neo"/>
+                <a:latin typeface="Apple SD Gothic Neo"/>
+              </a:rPr>
+              <a:t>Steps 2-5 are autonomous — no human intervention needed.</a:t>
+            </a:r>
+          </a:p>
+          <a:p>
+            <a:pPr>
+              <a:spcAft>
+                <a:spcPts val="400"/>
+              </a:spcAft>
+            </a:pPr>
+            <a:r>
+              <a:rPr b="1">
+                <a:ea typeface="Apple SD Gothic Neo"/>
+                <a:latin typeface="Apple SD Gothic Neo"/>
+              </a:rPr>
+              <a:t>Six Core Traits:</a:t>
+            </a:r>
+            <a:r>
+              <a:rPr b="0">
+                <a:ea typeface="Apple SD Gothic Neo"/>
+                <a:latin typeface="Apple SD Gothic Neo"/>
+              </a:rPr>
+              <a:t> Autonomy, Multi-step Reasoning, Tool Use, Memory, Adaptability, Goal Orientation</a:t>
+            </a:r>
+          </a:p>
+          <a:p>
+            <a:pPr>
+              <a:spcAft>
+                <a:spcPts val="400"/>
+              </a:spcAft>
+            </a:pPr>
+            <a:r>
+              <a:rPr b="1">
+                <a:ea typeface="Apple SD Gothic Neo"/>
+                <a:latin typeface="Apple SD Gothic Neo"/>
+              </a:rPr>
+              <a:t>AI Evolution:</a:t>
+            </a:r>
+          </a:p>
+          <a:p>
+            <a:pPr>
+              <a:spcAft>
+                <a:spcPts val="400"/>
+              </a:spcAft>
+            </a:pPr>
+            <a:r>
+              <a:rPr b="0">
                 <a:ea typeface="Apple SD Gothic Neo"/>
                 <a:latin typeface="Apple SD Gothic Neo"/>
               </a:rPr>
@@ -4701,7 +5251,7 @@
               </a:spcAft>
             </a:pPr>
             <a:r>
-              <a:rPr>
+              <a:rPr b="0">
                 <a:ea typeface="Apple SD Gothic Neo"/>
                 <a:latin typeface="Apple SD Gothic Neo"/>
               </a:rPr>
@@ -4715,7 +5265,7 @@
               </a:spcAft>
             </a:pPr>
             <a:r>
-              <a:rPr>
+              <a:rPr b="0">
                 <a:ea typeface="Apple SD Gothic Neo"/>
                 <a:latin typeface="Apple SD Gothic Neo"/>
               </a:rPr>
@@ -4729,7 +5279,7 @@
               </a:spcAft>
             </a:pPr>
             <a:r>
-              <a:rPr>
+              <a:rPr b="0">
                 <a:ea typeface="Apple SD Gothic Neo"/>
                 <a:latin typeface="Apple SD Gothic Neo"/>
               </a:rPr>
@@ -4743,11 +5293,60 @@
               </a:spcAft>
             </a:pPr>
             <a:r>
-              <a:rPr>
+              <a:rPr b="0">
                 <a:ea typeface="Apple SD Gothic Neo"/>
                 <a:latin typeface="Apple SD Gothic Neo"/>
               </a:rPr>
               <a:t>Gen 5: Multi-Agent Systems (2026, Agent Teams)</a:t>
+            </a:r>
+          </a:p>
+          <a:p>
+            <a:pPr>
+              <a:spcAft>
+                <a:spcPts val="400"/>
+              </a:spcAft>
+            </a:pPr>
+            <a:r>
+              <a:rPr b="1">
+                <a:ea typeface="Apple SD Gothic Neo"/>
+                <a:latin typeface="Apple SD Gothic Neo"/>
+              </a:rPr>
+              <a:t>Multi-Agent impact:</a:t>
+            </a:r>
+            <a:r>
+              <a:rPr b="0">
+                <a:ea typeface="Apple SD Gothic Neo"/>
+                <a:latin typeface="Apple SD Gothic Neo"/>
+              </a:rPr>
+              <a:t> Single agent = 1.7% actionable recommendations → Multi-agent = 100%</a:t>
+            </a:r>
+          </a:p>
+          <a:p>
+            <a:pPr>
+              <a:spcAft>
+                <a:spcPts val="400"/>
+              </a:spcAft>
+            </a:pPr>
+            <a:r>
+              <a:rPr b="0">
+                <a:ea typeface="Apple SD Gothic Neo"/>
+                <a:latin typeface="Apple SD Gothic Neo"/>
+              </a:rPr>
+              <a:t>Gartner: Multi-agent inquiries surged </a:t>
+            </a:r>
+            <a:r>
+              <a:rPr b="1">
+                <a:ea typeface="Apple SD Gothic Neo"/>
+                <a:latin typeface="Apple SD Gothic Neo"/>
+              </a:rPr>
+              <a:t>1,445%</a:t>
+            </a:r>
+            <a:r>
+              <a:rPr b="0">
+                <a:ea typeface="Apple SD Gothic Neo"/>
+                <a:latin typeface="Apple SD Gothic Neo"/>
+              </a:rPr>
+              <a:t>. Market: $7.8B → $52B+ by 2030.</a:t>
             </a:r>
           </a:p>
         </p:txBody>
@@ -4786,7 +5385,7 @@
           <a:lstStyle/>
           <a:p>
             <a:r>
-              <a:rPr>
+              <a:rPr b="0">
                 <a:ea typeface="Apple SD Gothic Neo"/>
                 <a:latin typeface="Apple SD Gothic Neo"/>
               </a:rPr>
@@ -4816,7 +5415,63 @@
               </a:spcAft>
             </a:pPr>
             <a:r>
-              <a:rPr>
+              <a:rPr b="1">
+                <a:ea typeface="Apple SD Gothic Neo"/>
+                <a:latin typeface="Apple SD Gothic Neo"/>
+              </a:rPr>
+              <a:t>What:</a:t>
+            </a:r>
+            <a:r>
+              <a:rPr b="0">
+                <a:ea typeface="Apple SD Gothic Neo"/>
+                <a:latin typeface="Apple SD Gothic Neo"/>
+              </a:rPr>
+              <a:t> Fair-code workflow automation (since 2019), 500+ integrations, self-hosted or cloud</a:t>
+            </a:r>
+          </a:p>
+          <a:p>
+            <a:pPr>
+              <a:spcAft>
+                <a:spcPts val="400"/>
+              </a:spcAft>
+            </a:pPr>
+            <a:r>
+              <a:rPr b="1">
+                <a:ea typeface="Apple SD Gothic Neo"/>
+                <a:latin typeface="Apple SD Gothic Neo"/>
+              </a:rPr>
+              <a:t>Scale:</a:t>
+            </a:r>
+            <a:r>
+              <a:rPr b="0">
+                <a:ea typeface="Apple SD Gothic Neo"/>
+                <a:latin typeface="Apple SD Gothic Neo"/>
+              </a:rPr>
+              <a:t> $2.5B valuation, Nvidia investment, 3,000+ enterprise customers, ARR $40M+</a:t>
+            </a:r>
+          </a:p>
+          <a:p>
+            <a:pPr>
+              <a:spcAft>
+                <a:spcPts val="400"/>
+              </a:spcAft>
+            </a:pPr>
+            <a:r>
+              <a:rPr b="1">
+                <a:ea typeface="Apple SD Gothic Neo"/>
+                <a:latin typeface="Apple SD Gothic Neo"/>
+              </a:rPr>
+              <a:t>Why n8n fits Agentic AI:</a:t>
+            </a:r>
+          </a:p>
+          <a:p>
+            <a:pPr>
+              <a:spcAft>
+                <a:spcPts val="400"/>
+              </a:spcAft>
+            </a:pPr>
+            <a:r>
+              <a:rPr b="0">
                 <a:ea typeface="Apple SD Gothic Neo"/>
                 <a:latin typeface="Apple SD Gothic Neo"/>
               </a:rPr>
@@ -4830,7 +5485,7 @@
               </a:spcAft>
             </a:pPr>
             <a:r>
-              <a:rPr>
+              <a:rPr b="0">
                 <a:ea typeface="Apple SD Gothic Neo"/>
                 <a:latin typeface="Apple SD Gothic Neo"/>
               </a:rPr>
@@ -4844,7 +5499,7 @@
               </a:spcAft>
             </a:pPr>
             <a:r>
-              <a:rPr>
+              <a:rPr b="0">
                 <a:ea typeface="Apple SD Gothic Neo"/>
                 <a:latin typeface="Apple SD Gothic Neo"/>
               </a:rPr>
@@ -4858,7 +5513,7 @@
               </a:spcAft>
             </a:pPr>
             <a:r>
-              <a:rPr>
+              <a:rPr b="0">
                 <a:ea typeface="Apple SD Gothic Neo"/>
                 <a:latin typeface="Apple SD Gothic Neo"/>
               </a:rPr>
@@ -4872,7 +5527,7 @@
               </a:spcAft>
             </a:pPr>
             <a:r>
-              <a:rPr>
+              <a:rPr b="0">
                 <a:ea typeface="Apple SD Gothic Neo"/>
                 <a:latin typeface="Apple SD Gothic Neo"/>
               </a:rPr>
@@ -4886,7 +5541,42 @@
               </a:spcAft>
             </a:pPr>
             <a:r>
-              <a:rPr>
+              <a:rPr b="1">
+                <a:ea typeface="Apple SD Gothic Neo"/>
+                <a:latin typeface="Apple SD Gothic Neo"/>
+              </a:rPr>
+              <a:t>Unique Position:</a:t>
+            </a:r>
+            <a:r>
+              <a:rPr b="0">
+                <a:ea typeface="Apple SD Gothic Neo"/>
+                <a:latin typeface="Apple SD Gothic Neo"/>
+              </a:rPr>
+              <a:t> Code flexibility + No-code speed = Sweet spot between LangGraph and Zapier</a:t>
+            </a:r>
+          </a:p>
+          <a:p>
+            <a:pPr>
+              <a:spcAft>
+                <a:spcPts val="400"/>
+              </a:spcAft>
+            </a:pPr>
+            <a:r>
+              <a:rPr b="1">
+                <a:ea typeface="Apple SD Gothic Neo"/>
+                <a:latin typeface="Apple SD Gothic Neo"/>
+              </a:rPr>
+              <a:t>Automotive Cases:</a:t>
+            </a:r>
+          </a:p>
+          <a:p>
+            <a:pPr>
+              <a:spcAft>
+                <a:spcPts val="400"/>
+              </a:spcAft>
+            </a:pPr>
+            <a:r>
+              <a:rPr b="0">
                 <a:ea typeface="Apple SD Gothic Neo"/>
                 <a:latin typeface="Apple SD Gothic Neo"/>
               </a:rPr>
@@ -4900,7 +5590,7 @@
               </a:spcAft>
             </a:pPr>
             <a:r>
-              <a:rPr>
+              <a:rPr b="0">
                 <a:ea typeface="Apple SD Gothic Neo"/>
                 <a:latin typeface="Apple SD Gothic Neo"/>
               </a:rPr>
@@ -4914,7 +5604,7 @@
               </a:spcAft>
             </a:pPr>
             <a:r>
-              <a:rPr>
+              <a:rPr b="0">
                 <a:ea typeface="Apple SD Gothic Neo"/>
                 <a:latin typeface="Apple SD Gothic Neo"/>
               </a:rPr>
@@ -4928,7 +5618,7 @@
               </a:spcAft>
             </a:pPr>
             <a:r>
-              <a:rPr>
+              <a:rPr b="0">
                 <a:ea typeface="Apple SD Gothic Neo"/>
                 <a:latin typeface="Apple SD Gothic Neo"/>
               </a:rPr>
@@ -4971,7 +5661,7 @@
           <a:lstStyle/>
           <a:p>
             <a:r>
-              <a:rPr>
+              <a:rPr b="0">
                 <a:ea typeface="Apple SD Gothic Neo"/>
                 <a:latin typeface="Apple SD Gothic Neo"/>
               </a:rPr>
@@ -4982,52 +5672,163 @@
       </p:sp>
       <p:sp>
         <p:nvSpPr>
-          <p:cNvPr id="3" name="Text Placeholder 2"/>
-          <p:cNvSpPr>
-            <a:spLocks noGrp="1"/>
-          </p:cNvSpPr>
-          <p:nvPr>
-            <p:ph type="body" idx="1"/>
-          </p:nvPr>
-        </p:nvSpPr>
-        <p:spPr/>
-        <p:txBody>
-          <a:bodyPr/>
-          <a:lstStyle/>
-          <a:p>
-            <a:r>
-              <a:rPr>
-                <a:ea typeface="Apple SD Gothic Neo"/>
-                <a:latin typeface="Apple SD Gothic Neo"/>
-              </a:rPr>
-              <a:t>• Week 1: Install n8n self-hosted, explore workflows</a:t>
-            </a:r>
-          </a:p>
-          <a:p>
-            <a:r>
-              <a:rPr>
-                <a:ea typeface="Apple SD Gothic Neo"/>
-                <a:latin typeface="Apple SD Gothic Neo"/>
-              </a:rPr>
-              <a:t>• Week 2: Build simple automation with AI Agent node</a:t>
-            </a:r>
-          </a:p>
-          <a:p>
-            <a:r>
-              <a:rPr>
-                <a:ea typeface="Apple SD Gothic Neo"/>
-                <a:latin typeface="Apple SD Gothic Neo"/>
-              </a:rPr>
-              <a:t>• Week 3: Convert one real business process to agentic workflow</a:t>
-            </a:r>
-          </a:p>
-          <a:p>
-            <a:r>
-              <a:rPr>
-                <a:ea typeface="Apple SD Gothic Neo"/>
-                <a:latin typeface="Apple SD Gothic Neo"/>
-              </a:rPr>
-              <a:t>• Week 4: Team review — Go / No-Go</a:t>
+          <p:cNvPr id="3" name="Content Placeholder 2"/>
+          <p:cNvSpPr>
+            <a:spLocks noGrp="1"/>
+          </p:cNvSpPr>
+          <p:nvPr>
+            <p:ph idx="1"/>
+          </p:nvPr>
+        </p:nvSpPr>
+        <p:spPr/>
+        <p:txBody>
+          <a:bodyPr/>
+          <a:lstStyle/>
+          <a:p>
+            <a:pPr>
+              <a:spcAft>
+                <a:spcPts val="400"/>
+              </a:spcAft>
+            </a:pPr>
+            <a:r>
+              <a:rPr b="1">
+                <a:ea typeface="Apple SD Gothic Neo"/>
+                <a:latin typeface="Apple SD Gothic Neo"/>
+              </a:rPr>
+              <a:t>The Big Picture:</a:t>
+            </a:r>
+          </a:p>
+          <a:p>
+            <a:pPr>
+              <a:spcAft>
+                <a:spcPts val="400"/>
+              </a:spcAft>
+            </a:pPr>
+            <a:r>
+              <a:rPr b="0">
+                <a:ea typeface="Apple SD Gothic Neo"/>
+                <a:latin typeface="Apple SD Gothic Neo"/>
+              </a:rPr>
+              <a:t>Models got smarter → Tools accessible → Code writes itself → Context managed → Agents work independently → Teams collaborate</a:t>
+            </a:r>
+          </a:p>
+          <a:p>
+            <a:pPr>
+              <a:spcAft>
+                <a:spcPts val="400"/>
+              </a:spcAft>
+            </a:pPr>
+            <a:r>
+              <a:rPr b="1">
+                <a:ea typeface="Apple SD Gothic Neo"/>
+                <a:latin typeface="Apple SD Gothic Neo"/>
+              </a:rPr>
+              <a:t>Why n8n:</a:t>
+            </a:r>
+            <a:r>
+              <a:rPr b="0">
+                <a:ea typeface="Apple SD Gothic Neo"/>
+                <a:latin typeface="Apple SD Gothic Neo"/>
+              </a:rPr>
+              <a:t> Low barrier, data sovereignty, 500+ connectors, bidirectional MCP, incremental adoption</a:t>
+            </a:r>
+          </a:p>
+          <a:p>
+            <a:pPr>
+              <a:spcAft>
+                <a:spcPts val="400"/>
+              </a:spcAft>
+            </a:pPr>
+            <a:r>
+              <a:rPr b="1">
+                <a:ea typeface="Apple SD Gothic Neo"/>
+                <a:latin typeface="Apple SD Gothic Neo"/>
+              </a:rPr>
+              <a:t>Proposed Next Steps:</a:t>
+            </a:r>
+          </a:p>
+          <a:p>
+            <a:pPr>
+              <a:spcAft>
+                <a:spcPts val="400"/>
+              </a:spcAft>
+            </a:pPr>
+            <a:r>
+              <a:rPr b="0">
+                <a:ea typeface="Apple SD Gothic Neo"/>
+                <a:latin typeface="Apple SD Gothic Neo"/>
+              </a:rPr>
+              <a:t>Week 1: Install n8n self-hosted, explore workflows</a:t>
+            </a:r>
+          </a:p>
+          <a:p>
+            <a:pPr>
+              <a:spcAft>
+                <a:spcPts val="400"/>
+              </a:spcAft>
+            </a:pPr>
+            <a:r>
+              <a:rPr b="0">
+                <a:ea typeface="Apple SD Gothic Neo"/>
+                <a:latin typeface="Apple SD Gothic Neo"/>
+              </a:rPr>
+              <a:t>Week 2: Build simple automation with AI Agent node</a:t>
+            </a:r>
+          </a:p>
+          <a:p>
+            <a:pPr>
+              <a:spcAft>
+                <a:spcPts val="400"/>
+              </a:spcAft>
+            </a:pPr>
+            <a:r>
+              <a:rPr b="0">
+                <a:ea typeface="Apple SD Gothic Neo"/>
+                <a:latin typeface="Apple SD Gothic Neo"/>
+              </a:rPr>
+              <a:t>Week 3: Convert one real business process to agentic workflow</a:t>
+            </a:r>
+          </a:p>
+          <a:p>
+            <a:pPr>
+              <a:spcAft>
+                <a:spcPts val="400"/>
+              </a:spcAft>
+            </a:pPr>
+            <a:r>
+              <a:rPr b="0">
+                <a:ea typeface="Apple SD Gothic Neo"/>
+                <a:latin typeface="Apple SD Gothic Neo"/>
+              </a:rPr>
+              <a:t>Week 4: Team review — Go / No-Go</a:t>
+            </a:r>
+          </a:p>
+          <a:p>
+            <a:pPr>
+              <a:spcAft>
+                <a:spcPts val="400"/>
+              </a:spcAft>
+            </a:pPr>
+            <a:r>
+              <a:rPr b="0">
+                <a:ea typeface="Apple SD Gothic Neo"/>
+                <a:latin typeface="Apple SD Gothic Neo"/>
+              </a:rPr>
+              <a:t>"The success of agentic AI depends not on the model, but on orchestration."</a:t>
+            </a:r>
+          </a:p>
+          <a:p>
+            <a:pPr>
+              <a:spcAft>
+                <a:spcPts val="400"/>
+              </a:spcAft>
+            </a:pPr>
+            <a:r>
+              <a:rPr b="0">
+                <a:ea typeface="Apple SD Gothic Neo"/>
+                <a:latin typeface="Apple SD Gothic Neo"/>
+              </a:rPr>
+              <a:t>The age of agentic AI has begun. n8n opens the door at the lowest threshold.</a:t>
             </a:r>
           </a:p>
         </p:txBody>

</xml_diff>